<commit_message>
Add BTM investor fixes, PV synthesis, project economics, and updated docs.
Wire BTM revenue guard, LP dispatch, and investment readiness gate; add PV specs input and CAPEX/OPEX/IRR for front-of-meter and BTM; expand tests to 71 and regenerate presentation.

Co-authored-by: Cursor <cursoragent@cursor.com>
</commit_message>
<xml_diff>
--- a/docs/Optimus_Mexico_Presentation.pptx
+++ b/docs/Optimus_Mexico_Presentation.pptx
@@ -3248,7 +3248,7 @@
               </a:defRPr>
             </a:pPr>
             <a:r>
-              <a:t>Module 2 — Investor decision layer</a:t>
+              <a:t>Module 2 — Investor layer &amp; savings IRR</a:t>
             </a:r>
           </a:p>
         </p:txBody>
@@ -3293,7 +3293,7 @@
               <a:defRPr sz="1400"/>
             </a:pPr>
             <a:r>
-              <a:t>Explicit costs: CAPEX (USD/kWh × FX), OPEX %/yr, insurance %/yr, financing (cash / lease / loan) and a configurable BESS life (default 20 years).</a:t>
+              <a:t>Explicit costs: CAPEX (PV USD/kWp + BESS USD/kWh × FX), OPEX %/yr, insurance %/yr, financing (cash / lease / loan) and configurable BESS life (default 20 years).</a:t>
             </a:r>
           </a:p>
           <a:p>
@@ -3304,7 +3304,7 @@
               <a:defRPr sz="1400"/>
             </a:pPr>
             <a:r>
-              <a:t>Conservative haircuts: savings confidence 90%, availability 95%, collection 95%; downside case stresses tariff spread and load.</a:t>
+              <a:t>IRR on CFE savings — unlevered (bill savings − OPEX vs CAPEX) and levered (bankable savings after financing); NPV and payback over BESS life.</a:t>
             </a:r>
           </a:p>
           <a:p>
@@ -3315,7 +3315,7 @@
               <a:defRPr sz="1400"/>
             </a:pPr>
             <a:r>
-              <a:t>Outputs: net monthly AND annual benefit (base/downside/upside), simple payback, NPV over BESS life, unlevered project IRR, red flags.</a:t>
+              <a:t>Investment readiness gate: DEMO | SCREENING | REVISE | INVESTMENT READY — GO/REVISE/NO-GO blocked unless INVESTMENT READY (sample data = DEMO).</a:t>
             </a:r>
           </a:p>
           <a:p>
@@ -3326,7 +3326,7 @@
               <a:defRPr sz="1400"/>
             </a:pPr>
             <a:r>
-              <a:t>Deterministic gate: GO / REVISE / NO-GO — reproducible from saved metrics.</a:t>
+              <a:t>Conservative haircuts on bankable savings; red flags; Excel investor package.</a:t>
             </a:r>
           </a:p>
           <a:p>
@@ -3337,7 +3337,7 @@
               <a:defRPr sz="1400"/>
             </a:pPr>
             <a:r>
-              <a:t>Sample result: payback 1.3 y, NPV(20y) MXN 15.6M, IRR 74.6% → GO.</a:t>
+              <a:t>Sub-workflows: Screening, Bankable Investor, Customer Proposal, Technical Dispatch.</a:t>
             </a:r>
           </a:p>
         </p:txBody>
@@ -3470,7 +3470,18 @@
               <a:defRPr sz="1600"/>
             </a:pPr>
             <a:r>
-              <a:t>Quality: 42 automated tests (tariff calendar, bill formulas, dispatch SOC and no-export constraints, financing math, recommendation gates).</a:t>
+              <a:t>Quality: 71 automated tests (wholesale dispatch, BTM tariff/bill/dispatch, BTM revenue guard, readiness gate, LP optimizer, PV synthesis, FOM economics).</a:t>
+            </a:r>
+          </a:p>
+          <a:p>
+            <a:pPr>
+              <a:spcAft>
+                <a:spcPts val="600"/>
+              </a:spcAft>
+              <a:defRPr sz="1600"/>
+            </a:pPr>
+            <a:r>
+              <a:t>New agents: pv_synthesis, fom_investor, btm_lp_optimizer, btm_revenue_guard, btm_investment_readiness.</a:t>
             </a:r>
           </a:p>
           <a:p>
@@ -3647,7 +3658,7 @@
               <a:defRPr sz="1700"/>
             </a:pPr>
             <a:r>
-              <a:t>Deliverables: interactive web app, Excel / Word / PDF / PowerPoint reports, investor-grade summaries, full pytest-verified calculation engine (42 tests).</a:t>
+              <a:t>Deliverables: interactive web app, Excel / Word / PDF / PowerPoint reports, investor-grade summaries with CAPEX/OPEX/IRR, full pytest-verified engine (71 tests).</a:t>
             </a:r>
           </a:p>
           <a:p>
@@ -3903,7 +3914,7 @@
               </a:defRPr>
             </a:pPr>
             <a:r>
-              <a:t>8,760 h PML prices + PV production profile</a:t>
+              <a:t>8,760 h PML + PV profile (upload or MW AC/MWp/yield specs)</a:t>
             </a:r>
           </a:p>
         </p:txBody>
@@ -4095,7 +4106,7 @@
               </a:defRPr>
             </a:pPr>
             <a:r>
-              <a:t>Excel, Word, PDF, PowerPoint + investor report</a:t>
+              <a:t>Excel, Word, PDF, PowerPoint + investor report + project IRR</a:t>
             </a:r>
           </a:p>
         </p:txBody>
@@ -4228,7 +4239,7 @@
               <a:defRPr sz="1500"/>
             </a:pPr>
             <a:r>
-              <a:t>1. Dispatch + PPA + Capacity — wholesale revenue analysis.</a:t>
+              <a:t>1. Front-of-Meter Dispatch + PPA + Capacity — wholesale revenue + CAPEX/OPEX/IRR.</a:t>
             </a:r>
           </a:p>
           <a:p>
@@ -4239,7 +4250,18 @@
               <a:defRPr sz="1500"/>
             </a:pPr>
             <a:r>
-              <a:t>2. Behind-the-Meter (CFE) — industrial bill-savings and investor case.</a:t>
+              <a:t>2. Behind-the-Meter (CFE) — bill savings, readiness gate, savings IRR.</a:t>
+            </a:r>
+          </a:p>
+          <a:p>
+            <a:pPr>
+              <a:spcAft>
+                <a:spcPts val="600"/>
+              </a:spcAft>
+              <a:defRPr sz="1500"/>
+            </a:pPr>
+            <a:r>
+              <a:t>PV input: upload a profile OR enter MW AC, MWp, yield and degradation.</a:t>
             </a:r>
           </a:p>
           <a:p>
@@ -4471,7 +4493,7 @@
               </a:defRPr>
             </a:pPr>
             <a:r>
-              <a:t>Module 1 — Dispatch, PPA &amp; Capacity (wholesale)</a:t>
+              <a:t>Module 1 — Front-of-Meter Dispatch, PPA &amp; Capacity</a:t>
             </a:r>
           </a:p>
         </p:txBody>
@@ -4505,7 +4527,7 @@
               <a:defRPr sz="1400"/>
             </a:pPr>
             <a:r>
-              <a:t>Merges 8,760 h of nodal PML prices with the PV production profile.</a:t>
+              <a:t>Merges 8,760 h of nodal PML prices with PV (upload or synthesized from specs).</a:t>
             </a:r>
           </a:p>
           <a:p>
@@ -4580,6 +4602,17 @@
             </a:pPr>
             <a:r>
               <a:t>Capacity market: 100 critical hours → accredited MW → MXN/year.</a:t>
+            </a:r>
+          </a:p>
+          <a:p>
+            <a:pPr>
+              <a:spcAft>
+                <a:spcPts val="600"/>
+              </a:spcAft>
+              <a:defRPr sz="1400"/>
+            </a:pPr>
+            <a:r>
+              <a:t>Project economics: PV+BESS CAPEX, OPEX/insurance, financing → unlevered &amp; levered IRR.</a:t>
             </a:r>
           </a:p>
         </p:txBody>
@@ -4656,7 +4689,7 @@
               </a:defRPr>
             </a:pPr>
             <a:r>
-              <a:t>Module 1 — Revenue results &amp; reports</a:t>
+              <a:t>Module 1 — Revenue &amp; project economics</a:t>
             </a:r>
           </a:p>
         </p:txBody>
@@ -4701,7 +4734,7 @@
               <a:defRPr sz="1500"/>
             </a:pPr>
             <a:r>
-              <a:t>Sample-data result: MXN 238M total revenue (PPA 104M + Capacity 68M + Merchant 61M).</a:t>
+              <a:t>Project economics panel: CAPEX (PV USD/kWp + BESS USD/kWh), OPEX, insurance, financing, project life → NPV, payback, unlevered and levered project IRR.</a:t>
             </a:r>
           </a:p>
           <a:p>
@@ -4712,7 +4745,18 @@
               <a:defRPr sz="1500"/>
             </a:pPr>
             <a:r>
-              <a:t>One click exports: Excel workbook, Word, PDF, PowerPoint — plus the investor report PDF with executive summary and disclaimer.</a:t>
+              <a:t>Sample-data result: MXN 238M total revenue (PPA + Capacity + Merchant).</a:t>
+            </a:r>
+          </a:p>
+          <a:p>
+            <a:pPr>
+              <a:spcAft>
+                <a:spcPts val="600"/>
+              </a:spcAft>
+              <a:defRPr sz="1500"/>
+            </a:pPr>
+            <a:r>
+              <a:t>One click exports: Excel workbook, Word, PDF, PowerPoint — plus investor report PDF.</a:t>
             </a:r>
           </a:p>
         </p:txBody>
@@ -4853,7 +4897,7 @@
               </a:defRPr>
             </a:pPr>
             <a:r>
-              <a:t>customer meter data; sample plant included</a:t>
+              <a:t>upload or PV specs (MW AC / MWp / yield)</a:t>
             </a:r>
           </a:p>
         </p:txBody>
@@ -4981,7 +5025,7 @@
               </a:defRPr>
             </a:pPr>
             <a:r>
-              <a:t>energy by period + capacity &amp; distribution demand (CNE 2026 formulas)</a:t>
+              <a:t>energy by period + capacity &amp; distribution demand</a:t>
             </a:r>
           </a:p>
         </p:txBody>
@@ -5033,7 +5077,7 @@
               </a:defRPr>
             </a:pPr>
             <a:r>
-              <a:t>BESS / PV+BESS dispatch</a:t>
+              <a:t>Dispatch engine</a:t>
             </a:r>
           </a:p>
           <a:p>
@@ -5045,7 +5089,7 @@
               </a:defRPr>
             </a:pPr>
             <a:r>
-              <a:t>no-export: peak shaving cap + TOU shifting + PV self-consumption</a:t>
+              <a:t>rule-based screening OR LP bankable (import-cap sweep)</a:t>
             </a:r>
           </a:p>
         </p:txBody>
@@ -5109,7 +5153,7 @@
               </a:defRPr>
             </a:pPr>
             <a:r>
-              <a:t>savings attributed by tariff component</a:t>
+              <a:t>savings by CFE tariff component; BTM-only revenues</a:t>
             </a:r>
           </a:p>
         </p:txBody>
@@ -5173,7 +5217,7 @@
               </a:defRPr>
             </a:pPr>
             <a:r>
-              <a:t>financing, haircuts, NPV/IRR over BESS life → GO / REVISE / NO-GO</a:t>
+              <a:t>readiness gate DEMO→INVESTMENT READY; IRR on CFE savings</a:t>
             </a:r>
           </a:p>
         </p:txBody>

</xml_diff>